<commit_message>
nav+footer: footer の Connect 列を全ページ同期 (LINE/Instagram/Phone)
▸ 18 ページの footer-col Connect 部分を一律に更新:
  Journal / Press & Media / Press Kit / Awards / Contact
  + 💬 LINE 公式アカウント (line.me/R/ti/p/@706sgiuq)
  + 📷 Instagram @eda_livestock
  + 📞 080-5793-0708 (tel: リンク)

▸ 訴求ポイント:
  - LINE / Instagram / 電話 へのアクセス導線を全ページから1クリックで到達
  - フッターは index/shop/checkout どこからでも同じ
  - 電話番号が tel: リンクなのでモバイルで即発信可能

Co-Authored-By: Claude Opus 4.7 (1M context) <noreply@anthropic.com>
</commit_message>
<xml_diff>
--- a/EDA-LIVESTOCK_営業資料_2026.pptx
+++ b/EDA-LIVESTOCK_営業資料_2026.pptx
@@ -15483,7 +15483,7 @@
         <p:spPr>
           <a:xfrm>
             <a:off x="609600" y="1523999"/>
-            <a:ext cx="1714500" cy="666750"/>
+            <a:ext cx="2095499" cy="685800"/>
           </a:xfrm>
           <a:prstGeom prst="rect">
             <a:avLst/>
@@ -15498,7 +15498,7 @@
           <a:p>
             <a:pPr algn="l"/>
             <a:r>
-              <a:rPr sz="5000" b="0" i="0">
+              <a:rPr sz="4400" b="0" i="0">
                 <a:solidFill>
                   <a:srgbClr val="D4A93B"/>
                 </a:solidFill>
@@ -15517,8 +15517,8 @@
         </p:nvSpPr>
         <p:spPr>
           <a:xfrm>
-            <a:off x="609600" y="2076449"/>
-            <a:ext cx="1714500" cy="190499"/>
+            <a:off x="609600" y="2247899"/>
+            <a:ext cx="2095499" cy="190499"/>
           </a:xfrm>
           <a:prstGeom prst="rect">
             <a:avLst/>
@@ -15533,9 +15533,9 @@
           <a:p>
             <a:pPr algn="l"/>
             <a:r>
-              <a:rPr sz="900" b="0" i="0" spc="18">
-                <a:solidFill>
-                  <a:srgbClr val="849690"/>
+              <a:rPr sz="1000" b="0" i="0" spc="18">
+                <a:solidFill>
+                  <a:srgbClr val="90A09B"/>
                 </a:solidFill>
                 <a:latin typeface="Bebas Neue"/>
               </a:rPr>
@@ -15552,8 +15552,8 @@
         </p:nvSpPr>
         <p:spPr>
           <a:xfrm>
-            <a:off x="2133599" y="1523999"/>
-            <a:ext cx="1714500" cy="666750"/>
+            <a:off x="2419349" y="1523999"/>
+            <a:ext cx="2095499" cy="685800"/>
           </a:xfrm>
           <a:prstGeom prst="rect">
             <a:avLst/>
@@ -15568,7 +15568,7 @@
           <a:p>
             <a:pPr algn="l"/>
             <a:r>
-              <a:rPr sz="5000" b="0" i="0">
+              <a:rPr sz="4400" b="0" i="0">
                 <a:solidFill>
                   <a:srgbClr val="D4A93B"/>
                 </a:solidFill>
@@ -15587,8 +15587,8 @@
         </p:nvSpPr>
         <p:spPr>
           <a:xfrm>
-            <a:off x="2133599" y="2076449"/>
-            <a:ext cx="1714500" cy="190499"/>
+            <a:off x="2419349" y="2247899"/>
+            <a:ext cx="2095499" cy="190499"/>
           </a:xfrm>
           <a:prstGeom prst="rect">
             <a:avLst/>
@@ -15603,9 +15603,9 @@
           <a:p>
             <a:pPr algn="l"/>
             <a:r>
-              <a:rPr sz="900" b="0" i="0" spc="18">
-                <a:solidFill>
-                  <a:srgbClr val="849690"/>
+              <a:rPr sz="1000" b="0" i="0" spc="18">
+                <a:solidFill>
+                  <a:srgbClr val="90A09B"/>
                 </a:solidFill>
                 <a:latin typeface="Bebas Neue"/>
               </a:rPr>
@@ -15622,8 +15622,8 @@
         </p:nvSpPr>
         <p:spPr>
           <a:xfrm>
-            <a:off x="3657600" y="1523999"/>
-            <a:ext cx="1714500" cy="666750"/>
+            <a:off x="4229100" y="1523999"/>
+            <a:ext cx="2095499" cy="685800"/>
           </a:xfrm>
           <a:prstGeom prst="rect">
             <a:avLst/>
@@ -15637,7 +15637,7 @@
           <a:lstStyle/>
           <a:p>
             <a:r>
-              <a:rPr sz="5000" b="0" i="0">
+              <a:rPr sz="4400" b="0" i="0">
                 <a:solidFill>
                   <a:srgbClr val="D4A93B"/>
                 </a:solidFill>
@@ -15646,7 +15646,7 @@
               <a:t>100</a:t>
             </a:r>
             <a:r>
-              <a:rPr sz="2500" b="0" i="0">
+              <a:rPr sz="2200" b="0" i="0">
                 <a:solidFill>
                   <a:srgbClr val="D4A93B"/>
                 </a:solidFill>
@@ -15665,8 +15665,8 @@
         </p:nvSpPr>
         <p:spPr>
           <a:xfrm>
-            <a:off x="3657600" y="2076449"/>
-            <a:ext cx="1714500" cy="190499"/>
+            <a:off x="4229100" y="2247899"/>
+            <a:ext cx="2095499" cy="190499"/>
           </a:xfrm>
           <a:prstGeom prst="rect">
             <a:avLst/>
@@ -15681,9 +15681,9 @@
           <a:p>
             <a:pPr algn="l"/>
             <a:r>
-              <a:rPr sz="900" b="0" i="0" spc="18">
-                <a:solidFill>
-                  <a:srgbClr val="849690"/>
+              <a:rPr sz="1000" b="0" i="0" spc="18">
+                <a:solidFill>
+                  <a:srgbClr val="90A09B"/>
                 </a:solidFill>
                 <a:latin typeface="Bebas Neue"/>
               </a:rPr>
@@ -15700,7 +15700,7 @@
         </p:nvSpPr>
         <p:spPr>
           <a:xfrm>
-            <a:off x="609600" y="2571750"/>
+            <a:off x="609600" y="2762249"/>
             <a:ext cx="5143500" cy="171450"/>
           </a:xfrm>
           <a:prstGeom prst="rect">
@@ -15735,7 +15735,7 @@
         </p:nvCxnSpPr>
         <p:spPr>
           <a:xfrm>
-            <a:off x="609600" y="2800350"/>
+            <a:off x="609600" y="2990849"/>
             <a:ext cx="5143499" cy="0"/>
           </a:xfrm>
           <a:prstGeom prst="line">
@@ -15770,7 +15770,7 @@
         </p:nvSpPr>
         <p:spPr>
           <a:xfrm>
-            <a:off x="609600" y="2905124"/>
+            <a:off x="609600" y="3095625"/>
             <a:ext cx="1028700" cy="228600"/>
           </a:xfrm>
           <a:prstGeom prst="rect">
@@ -15814,7 +15814,7 @@
         </p:nvSpPr>
         <p:spPr>
           <a:xfrm>
-            <a:off x="666750" y="2905124"/>
+            <a:off x="666750" y="3095625"/>
             <a:ext cx="914400" cy="228600"/>
           </a:xfrm>
           <a:prstGeom prst="rect">
@@ -15849,7 +15849,7 @@
         </p:nvSpPr>
         <p:spPr>
           <a:xfrm>
-            <a:off x="1695449" y="2905124"/>
+            <a:off x="1695449" y="3095625"/>
             <a:ext cx="1028700" cy="228600"/>
           </a:xfrm>
           <a:prstGeom prst="rect">
@@ -15893,7 +15893,7 @@
         </p:nvSpPr>
         <p:spPr>
           <a:xfrm>
-            <a:off x="1752599" y="2905124"/>
+            <a:off x="1752599" y="3095625"/>
             <a:ext cx="914400" cy="228600"/>
           </a:xfrm>
           <a:prstGeom prst="rect">
@@ -15928,7 +15928,7 @@
         </p:nvSpPr>
         <p:spPr>
           <a:xfrm>
-            <a:off x="2781300" y="2905124"/>
+            <a:off x="2781300" y="3095625"/>
             <a:ext cx="952499" cy="228600"/>
           </a:xfrm>
           <a:prstGeom prst="rect">
@@ -15972,7 +15972,7 @@
         </p:nvSpPr>
         <p:spPr>
           <a:xfrm>
-            <a:off x="2838450" y="2905124"/>
+            <a:off x="2838450" y="3095625"/>
             <a:ext cx="838200" cy="228600"/>
           </a:xfrm>
           <a:prstGeom prst="rect">
@@ -16007,7 +16007,7 @@
         </p:nvSpPr>
         <p:spPr>
           <a:xfrm>
-            <a:off x="3790949" y="2905124"/>
+            <a:off x="3790949" y="3095625"/>
             <a:ext cx="876299" cy="228600"/>
           </a:xfrm>
           <a:prstGeom prst="rect">
@@ -16051,7 +16051,7 @@
         </p:nvSpPr>
         <p:spPr>
           <a:xfrm>
-            <a:off x="3848099" y="2905124"/>
+            <a:off x="3848099" y="3095625"/>
             <a:ext cx="761999" cy="228600"/>
           </a:xfrm>
           <a:prstGeom prst="rect">
@@ -16086,7 +16086,7 @@
         </p:nvSpPr>
         <p:spPr>
           <a:xfrm>
-            <a:off x="4724399" y="2905124"/>
+            <a:off x="4724399" y="3095625"/>
             <a:ext cx="800100" cy="228600"/>
           </a:xfrm>
           <a:prstGeom prst="rect">
@@ -16130,7 +16130,7 @@
         </p:nvSpPr>
         <p:spPr>
           <a:xfrm>
-            <a:off x="4781549" y="2905124"/>
+            <a:off x="4781549" y="3095625"/>
             <a:ext cx="685800" cy="228600"/>
           </a:xfrm>
           <a:prstGeom prst="rect">
@@ -16165,7 +16165,7 @@
         </p:nvSpPr>
         <p:spPr>
           <a:xfrm>
-            <a:off x="609600" y="3190874"/>
+            <a:off x="609600" y="3381375"/>
             <a:ext cx="952499" cy="228600"/>
           </a:xfrm>
           <a:prstGeom prst="rect">
@@ -16209,7 +16209,7 @@
         </p:nvSpPr>
         <p:spPr>
           <a:xfrm>
-            <a:off x="666750" y="3190874"/>
+            <a:off x="666750" y="3381375"/>
             <a:ext cx="838200" cy="228600"/>
           </a:xfrm>
           <a:prstGeom prst="rect">
@@ -16244,7 +16244,7 @@
         </p:nvSpPr>
         <p:spPr>
           <a:xfrm>
-            <a:off x="1619250" y="3190874"/>
+            <a:off x="1619250" y="3381375"/>
             <a:ext cx="1028700" cy="228600"/>
           </a:xfrm>
           <a:prstGeom prst="rect">
@@ -16288,7 +16288,7 @@
         </p:nvSpPr>
         <p:spPr>
           <a:xfrm>
-            <a:off x="1676400" y="3190874"/>
+            <a:off x="1676400" y="3381375"/>
             <a:ext cx="914400" cy="228600"/>
           </a:xfrm>
           <a:prstGeom prst="rect">
@@ -16323,7 +16323,7 @@
         </p:nvSpPr>
         <p:spPr>
           <a:xfrm>
-            <a:off x="609600" y="3619499"/>
+            <a:off x="609600" y="3809999"/>
             <a:ext cx="5143500" cy="171450"/>
           </a:xfrm>
           <a:prstGeom prst="rect">
@@ -16358,7 +16358,7 @@
         </p:nvCxnSpPr>
         <p:spPr>
           <a:xfrm>
-            <a:off x="609600" y="3848099"/>
+            <a:off x="609600" y="4038599"/>
             <a:ext cx="5143499" cy="0"/>
           </a:xfrm>
           <a:prstGeom prst="line">
@@ -16393,7 +16393,7 @@
         </p:nvSpPr>
         <p:spPr>
           <a:xfrm>
-            <a:off x="609600" y="3952874"/>
+            <a:off x="609600" y="4143375"/>
             <a:ext cx="876299" cy="228600"/>
           </a:xfrm>
           <a:prstGeom prst="rect">
@@ -16437,7 +16437,7 @@
         </p:nvSpPr>
         <p:spPr>
           <a:xfrm>
-            <a:off x="666750" y="3952874"/>
+            <a:off x="666750" y="4143375"/>
             <a:ext cx="761999" cy="228600"/>
           </a:xfrm>
           <a:prstGeom prst="rect">
@@ -16472,7 +16472,7 @@
         </p:nvSpPr>
         <p:spPr>
           <a:xfrm>
-            <a:off x="1543050" y="3952874"/>
+            <a:off x="1543050" y="4143375"/>
             <a:ext cx="876299" cy="228600"/>
           </a:xfrm>
           <a:prstGeom prst="rect">
@@ -16516,7 +16516,7 @@
         </p:nvSpPr>
         <p:spPr>
           <a:xfrm>
-            <a:off x="1600200" y="3952874"/>
+            <a:off x="1600200" y="4143375"/>
             <a:ext cx="761999" cy="228600"/>
           </a:xfrm>
           <a:prstGeom prst="rect">
@@ -16551,7 +16551,7 @@
         </p:nvSpPr>
         <p:spPr>
           <a:xfrm>
-            <a:off x="2476499" y="3952874"/>
+            <a:off x="2476499" y="4143375"/>
             <a:ext cx="723900" cy="228600"/>
           </a:xfrm>
           <a:prstGeom prst="rect">
@@ -16595,7 +16595,7 @@
         </p:nvSpPr>
         <p:spPr>
           <a:xfrm>
-            <a:off x="2533649" y="3952874"/>
+            <a:off x="2533649" y="4143375"/>
             <a:ext cx="609600" cy="228600"/>
           </a:xfrm>
           <a:prstGeom prst="rect">
@@ -16630,7 +16630,7 @@
         </p:nvSpPr>
         <p:spPr>
           <a:xfrm>
-            <a:off x="3257550" y="3952874"/>
+            <a:off x="3257550" y="4143375"/>
             <a:ext cx="723900" cy="228600"/>
           </a:xfrm>
           <a:prstGeom prst="rect">
@@ -16674,7 +16674,7 @@
         </p:nvSpPr>
         <p:spPr>
           <a:xfrm>
-            <a:off x="3314700" y="3952874"/>
+            <a:off x="3314700" y="4143375"/>
             <a:ext cx="609600" cy="228600"/>
           </a:xfrm>
           <a:prstGeom prst="rect">
@@ -16709,7 +16709,7 @@
         </p:nvSpPr>
         <p:spPr>
           <a:xfrm>
-            <a:off x="6286500" y="2571750"/>
+            <a:off x="6286500" y="2762249"/>
             <a:ext cx="5143500" cy="171450"/>
           </a:xfrm>
           <a:prstGeom prst="rect">
@@ -16744,7 +16744,7 @@
         </p:nvCxnSpPr>
         <p:spPr>
           <a:xfrm>
-            <a:off x="6286500" y="2800350"/>
+            <a:off x="6286500" y="2990849"/>
             <a:ext cx="5143500" cy="0"/>
           </a:xfrm>
           <a:prstGeom prst="line">
@@ -16779,7 +16779,7 @@
         </p:nvSpPr>
         <p:spPr>
           <a:xfrm>
-            <a:off x="6286500" y="2905124"/>
+            <a:off x="6286500" y="3095625"/>
             <a:ext cx="1409699" cy="228600"/>
           </a:xfrm>
           <a:prstGeom prst="rect">
@@ -16823,7 +16823,7 @@
         </p:nvSpPr>
         <p:spPr>
           <a:xfrm>
-            <a:off x="6343650" y="2905124"/>
+            <a:off x="6343650" y="3095625"/>
             <a:ext cx="1295399" cy="228600"/>
           </a:xfrm>
           <a:prstGeom prst="rect">
@@ -16858,7 +16858,7 @@
         </p:nvSpPr>
         <p:spPr>
           <a:xfrm>
-            <a:off x="6286500" y="3429000"/>
+            <a:off x="6286500" y="3619499"/>
             <a:ext cx="5143500" cy="171450"/>
           </a:xfrm>
           <a:prstGeom prst="rect">
@@ -16893,7 +16893,7 @@
         </p:nvCxnSpPr>
         <p:spPr>
           <a:xfrm>
-            <a:off x="6286500" y="3657600"/>
+            <a:off x="6286500" y="3848099"/>
             <a:ext cx="5143500" cy="0"/>
           </a:xfrm>
           <a:prstGeom prst="line">
@@ -16928,7 +16928,7 @@
         </p:nvSpPr>
         <p:spPr>
           <a:xfrm>
-            <a:off x="6286500" y="3762374"/>
+            <a:off x="6286500" y="3952874"/>
             <a:ext cx="1028700" cy="228600"/>
           </a:xfrm>
           <a:prstGeom prst="rect">
@@ -16972,7 +16972,7 @@
         </p:nvSpPr>
         <p:spPr>
           <a:xfrm>
-            <a:off x="6343650" y="3762374"/>
+            <a:off x="6343650" y="3952874"/>
             <a:ext cx="914400" cy="228600"/>
           </a:xfrm>
           <a:prstGeom prst="rect">
@@ -17007,8 +17007,8 @@
         </p:nvCxnSpPr>
         <p:spPr>
           <a:xfrm>
-            <a:off x="6210299" y="4286250"/>
-            <a:ext cx="5219701" cy="0"/>
+            <a:off x="6591300" y="4476750"/>
+            <a:ext cx="5219700" cy="0"/>
           </a:xfrm>
           <a:prstGeom prst="line">
             <a:avLst/>
@@ -17042,8 +17042,8 @@
         </p:nvSpPr>
         <p:spPr>
           <a:xfrm>
-            <a:off x="6286500" y="5010149"/>
-            <a:ext cx="457200" cy="266699"/>
+            <a:off x="6667499" y="5181599"/>
+            <a:ext cx="761999" cy="266699"/>
           </a:xfrm>
           <a:prstGeom prst="rect">
             <a:avLst/>
@@ -17058,7 +17058,7 @@
           <a:p>
             <a:pPr algn="ctr"/>
             <a:r>
-              <a:rPr sz="2000" b="0" i="0">
+              <a:rPr sz="2200" b="0" i="0">
                 <a:solidFill>
                   <a:srgbClr val="D4A93B"/>
                 </a:solidFill>
@@ -17077,7 +17077,7 @@
         </p:nvSpPr>
         <p:spPr>
           <a:xfrm>
-            <a:off x="6286500" y="5295899"/>
+            <a:off x="6819900" y="5486400"/>
             <a:ext cx="457200" cy="228600"/>
           </a:xfrm>
           <a:prstGeom prst="rect">
@@ -17123,8 +17123,8 @@
         </p:nvSpPr>
         <p:spPr>
           <a:xfrm>
-            <a:off x="6286500" y="5524499"/>
-            <a:ext cx="457200" cy="190499"/>
+            <a:off x="6667499" y="5715000"/>
+            <a:ext cx="761999" cy="190499"/>
           </a:xfrm>
           <a:prstGeom prst="rect">
             <a:avLst/>
@@ -17158,8 +17158,8 @@
         </p:nvSpPr>
         <p:spPr>
           <a:xfrm>
-            <a:off x="7124699" y="4476750"/>
-            <a:ext cx="457200" cy="266699"/>
+            <a:off x="7715250" y="4743450"/>
+            <a:ext cx="761999" cy="266699"/>
           </a:xfrm>
           <a:prstGeom prst="rect">
             <a:avLst/>
@@ -17174,7 +17174,7 @@
           <a:p>
             <a:pPr algn="ctr"/>
             <a:r>
-              <a:rPr sz="2000" b="0" i="0">
+              <a:rPr sz="2200" b="0" i="0">
                 <a:solidFill>
                   <a:srgbClr val="D4A93B"/>
                 </a:solidFill>
@@ -17193,8 +17193,8 @@
         </p:nvSpPr>
         <p:spPr>
           <a:xfrm>
-            <a:off x="7124699" y="4762500"/>
-            <a:ext cx="457200" cy="761999"/>
+            <a:off x="7867649" y="5048250"/>
+            <a:ext cx="457200" cy="666750"/>
           </a:xfrm>
           <a:prstGeom prst="rect">
             <a:avLst/>
@@ -17239,8 +17239,8 @@
         </p:nvSpPr>
         <p:spPr>
           <a:xfrm>
-            <a:off x="7124699" y="5524499"/>
-            <a:ext cx="457200" cy="190499"/>
+            <a:off x="7715250" y="5715000"/>
+            <a:ext cx="761999" cy="190499"/>
           </a:xfrm>
           <a:prstGeom prst="rect">
             <a:avLst/>
@@ -17274,8 +17274,8 @@
         </p:nvSpPr>
         <p:spPr>
           <a:xfrm>
-            <a:off x="7962899" y="3905249"/>
-            <a:ext cx="457200" cy="266699"/>
+            <a:off x="8762999" y="4267199"/>
+            <a:ext cx="761999" cy="266699"/>
           </a:xfrm>
           <a:prstGeom prst="rect">
             <a:avLst/>
@@ -17290,7 +17290,7 @@
           <a:p>
             <a:pPr algn="ctr"/>
             <a:r>
-              <a:rPr sz="2000" b="0" i="0">
+              <a:rPr sz="2200" b="0" i="0">
                 <a:solidFill>
                   <a:srgbClr val="D4A93B"/>
                 </a:solidFill>
@@ -17309,8 +17309,8 @@
         </p:nvSpPr>
         <p:spPr>
           <a:xfrm>
-            <a:off x="7962899" y="4190999"/>
-            <a:ext cx="457200" cy="1333500"/>
+            <a:off x="8915400" y="4572000"/>
+            <a:ext cx="457200" cy="1143000"/>
           </a:xfrm>
           <a:prstGeom prst="rect">
             <a:avLst/>
@@ -17355,8 +17355,8 @@
         </p:nvSpPr>
         <p:spPr>
           <a:xfrm>
-            <a:off x="7962899" y="5524499"/>
-            <a:ext cx="457200" cy="190499"/>
+            <a:off x="8762999" y="5715000"/>
+            <a:ext cx="761999" cy="190499"/>
           </a:xfrm>
           <a:prstGeom prst="rect">
             <a:avLst/>

</xml_diff>